<commit_message>
docs: Update presentation deck with merged ATS slide, 3 GitHub image slots, and feature-first descriptions
</commit_message>
<xml_diff>
--- a/CareerPilot_AI_Presentation.pptx
+++ b/CareerPilot_AI_Presentation.pptx
@@ -20,7 +20,6 @@
     <p:sldId id="268" r:id="rId19"/>
     <p:sldId id="269" r:id="rId20"/>
     <p:sldId id="270" r:id="rId21"/>
-    <p:sldId id="271" r:id="rId22"/>
   </p:sldIdLst>
   <p:sldSz cx="12191695" cy="6858000" type="screen4x3"/>
   <p:notesSz cx="6858000" cy="9144000"/>
@@ -3423,7 +3422,7 @@
               </a:defRPr>
             </a:pPr>
             <a:r>
-              <a:t>9. Vector Search Job Matching (pgvector)</a:t>
+              <a:t>9. Dynamic AI Roadmap Generator</a:t>
             </a:r>
           </a:p>
           <a:p>
@@ -3439,7 +3438,7 @@
               </a:defRPr>
             </a:pPr>
             <a:r>
-              <a:t>Feature Highlight 6: Cosine Similarity Matching</a:t>
+              <a:t>Feature Highlight 6: Personalized Step-by-Step Learning Plans</a:t>
             </a:r>
           </a:p>
         </p:txBody>
@@ -3523,7 +3522,7 @@
               </a:defRPr>
             </a:pPr>
             <a:r>
-              <a:t>• Embeds target job requirements and candidate profiles into 384-dim vector space.</a:t>
+              <a:t>• Automated Skill Gap Detection: Compares current candidate capabilities against target job requirements to identify missing skills.</a:t>
             </a:r>
           </a:p>
           <a:p>
@@ -3539,7 +3538,7 @@
               </a:defRPr>
             </a:pPr>
             <a:r>
-              <a:t>• HNSW Indexing provides sub-millisecond similarity search.</a:t>
+              <a:t>• Structured Milestones: Builds a phased learning blueprint (Foundations, Advanced Tools, Hands-On Projects).</a:t>
             </a:r>
           </a:p>
           <a:p>
@@ -3555,7 +3554,7 @@
               </a:defRPr>
             </a:pPr>
             <a:r>
-              <a:t>• Displays real-time similarity match percentages (e.g. 88% Match).</a:t>
+              <a:t>• Actionable Guidance: Provides estimated completion timeframes and curated resources for every milestone.</a:t>
             </a:r>
           </a:p>
         </p:txBody>
@@ -3636,7 +3635,7 @@
               </a:defRPr>
             </a:pPr>
             <a:r>
-              <a:t>[ 🖼️ INSERT SCREENSHOT HERE: Role Analysis &amp; Cosine Similarity Match Cards ]</a:t>
+              <a:t>[ 🖼️ INSERT SCREENSHOT HERE: AI Roadmap Modal &amp; Phased Milestone Progression ]</a:t>
             </a:r>
           </a:p>
         </p:txBody>
@@ -3772,7 +3771,7 @@
           <a:lstStyle/>
           <a:p>
             <a:pPr>
-              <a:defRPr sz="2800" b="1">
+              <a:defRPr sz="3200" b="1">
                 <a:solidFill>
                   <a:srgbClr val="F1F5F9"/>
                 </a:solidFill>
@@ -3780,15 +3779,15 @@
               </a:defRPr>
             </a:pPr>
             <a:r>
-              <a:t>10. Kaggle AI Dataset Benchmark</a:t>
+              <a:t>10. Playwright Scraping Microservice</a:t>
             </a:r>
           </a:p>
           <a:p>
             <a:pPr>
               <a:spcBef>
-                <a:spcPts val="400"/>
+                <a:spcPts val="600"/>
               </a:spcBef>
-              <a:defRPr sz="1500">
+              <a:defRPr sz="1600">
                 <a:solidFill>
                   <a:srgbClr val="94A3B8"/>
                 </a:solidFill>
@@ -3796,7 +3795,7 @@
               </a:defRPr>
             </a:pPr>
             <a:r>
-              <a:t>Feature Highlight 7: Industry Job Ingestion</a:t>
+              <a:t>Feature Highlight 7: Autonomous Web Data Extraction (No Image Slot)</a:t>
             </a:r>
           </a:p>
         </p:txBody>
@@ -3810,7 +3809,7 @@
         <p:spPr>
           <a:xfrm>
             <a:off x="731520" y="1645920"/>
-            <a:ext cx="4754880" cy="4572000"/>
+            <a:ext cx="10728655" cy="4572000"/>
           </a:xfrm>
           <a:prstGeom prst="roundRect">
             <a:avLst/>
@@ -3854,8 +3853,8 @@
         </p:nvSpPr>
         <p:spPr>
           <a:xfrm>
-            <a:off x="914400" y="1828800"/>
-            <a:ext cx="4389120" cy="4206240"/>
+            <a:off x="1097280" y="2011680"/>
+            <a:ext cx="9997135" cy="3840480"/>
           </a:xfrm>
           <a:prstGeom prst="rect">
             <a:avLst/>
@@ -3870,9 +3869,9 @@
           <a:p>
             <a:pPr>
               <a:spcAft>
-                <a:spcPts val="1400"/>
+                <a:spcPts val="2000"/>
               </a:spcAft>
-              <a:defRPr sz="1500">
+              <a:defRPr sz="1800">
                 <a:solidFill>
                   <a:srgbClr val="F1F5F9"/>
                 </a:solidFill>
@@ -3880,15 +3879,15 @@
               </a:defRPr>
             </a:pPr>
             <a:r>
-              <a:t>• Ingests thousands of real AI &amp; software engineering job postings.</a:t>
+              <a:t>• Live Job Extraction: Automatically crawls job listings and career portals to pull full job descriptions and requirement details.</a:t>
             </a:r>
           </a:p>
           <a:p>
             <a:pPr>
               <a:spcAft>
-                <a:spcPts val="1400"/>
+                <a:spcPts val="2000"/>
               </a:spcAft>
-              <a:defRPr sz="1500">
+              <a:defRPr sz="1800">
                 <a:solidFill>
                   <a:srgbClr val="F1F5F9"/>
                 </a:solidFill>
@@ -3896,15 +3895,15 @@
               </a:defRPr>
             </a:pPr>
             <a:r>
-              <a:t>• Automatic embedding generation using Xenova/Sentence-Transformers.</a:t>
+              <a:t>• Dual Scraping Modes: Supports fast automated browser extraction as well as AI-assisted page parsing.</a:t>
             </a:r>
           </a:p>
           <a:p>
             <a:pPr>
               <a:spcAft>
-                <a:spcPts val="1400"/>
+                <a:spcPts val="2000"/>
               </a:spcAft>
-              <a:defRPr sz="1500">
+              <a:defRPr sz="1800">
                 <a:solidFill>
                   <a:srgbClr val="F1F5F9"/>
                 </a:solidFill>
@@ -3912,88 +3911,7 @@
               </a:defRPr>
             </a:pPr>
             <a:r>
-              <a:t>• Provides market benchmarks for salary, skills demand, and role requirements.</a:t>
-            </a:r>
-          </a:p>
-        </p:txBody>
-      </p:sp>
-      <p:sp>
-        <p:nvSpPr>
-          <p:cNvPr id="7" name="Rounded Rectangle 6"/>
-          <p:cNvSpPr/>
-          <p:nvPr/>
-        </p:nvSpPr>
-        <p:spPr>
-          <a:xfrm>
-            <a:off x="5760720" y="1645920"/>
-            <a:ext cx="5669280" cy="4572000"/>
-          </a:xfrm>
-          <a:prstGeom prst="roundRect">
-            <a:avLst/>
-          </a:prstGeom>
-          <a:solidFill>
-            <a:srgbClr val="18202F"/>
-          </a:solidFill>
-          <a:ln w="25400">
-            <a:solidFill>
-              <a:srgbClr val="A855F7"/>
-            </a:solidFill>
-          </a:ln>
-        </p:spPr>
-        <p:style>
-          <a:lnRef idx="1">
-            <a:schemeClr val="accent1"/>
-          </a:lnRef>
-          <a:fillRef idx="3">
-            <a:schemeClr val="accent1"/>
-          </a:fillRef>
-          <a:effectRef idx="2">
-            <a:schemeClr val="accent1"/>
-          </a:effectRef>
-          <a:fontRef idx="minor">
-            <a:schemeClr val="lt1"/>
-          </a:fontRef>
-        </p:style>
-        <p:txBody>
-          <a:bodyPr rtlCol="0" anchor="ctr"/>
-          <a:lstStyle/>
-          <a:p>
-            <a:pPr algn="ctr"/>
-          </a:p>
-        </p:txBody>
-      </p:sp>
-      <p:sp>
-        <p:nvSpPr>
-          <p:cNvPr id="8" name="TextBox 7"/>
-          <p:cNvSpPr txBox="1"/>
-          <p:nvPr/>
-        </p:nvSpPr>
-        <p:spPr>
-          <a:xfrm>
-            <a:off x="5943600" y="3291840"/>
-            <a:ext cx="5303520" cy="1645920"/>
-          </a:xfrm>
-          <a:prstGeom prst="rect">
-            <a:avLst/>
-          </a:prstGeom>
-          <a:noFill/>
-        </p:spPr>
-        <p:txBody>
-          <a:bodyPr wrap="square">
-            <a:spAutoFit/>
-          </a:bodyPr>
-          <a:lstStyle/>
-          <a:p>
-            <a:pPr algn="ctr">
-              <a:defRPr sz="1500" b="1">
-                <a:solidFill>
-                  <a:srgbClr val="A855F7"/>
-                </a:solidFill>
-                <a:latin typeface="Arial"/>
-              </a:defRPr>
-            </a:pPr>
-            <a:r>
-              <a:t>[ 🖼️ INSERT SCREENSHOT HERE: Kaggle AI Dataset Search &amp; Benchmarks ]</a:t>
+              <a:t>• Multi-Format Data Export: Enables candidates and recruiters to download extracted job data in JSON, CSV, Text, Markdown, or Terraform format.</a:t>
             </a:r>
           </a:p>
         </p:txBody>
@@ -4129,7 +4047,7 @@
           <a:lstStyle/>
           <a:p>
             <a:pPr>
-              <a:defRPr sz="2800" b="1">
+              <a:defRPr sz="3200" b="1">
                 <a:solidFill>
                   <a:srgbClr val="F1F5F9"/>
                 </a:solidFill>
@@ -4137,15 +4055,15 @@
               </a:defRPr>
             </a:pPr>
             <a:r>
-              <a:t>11. Dynamic AI Roadmap Generator</a:t>
+              <a:t>11. IBM Bob Skill Normalization &amp; Verification</a:t>
             </a:r>
           </a:p>
           <a:p>
             <a:pPr>
               <a:spcBef>
-                <a:spcPts val="400"/>
+                <a:spcPts val="600"/>
               </a:spcBef>
-              <a:defRPr sz="1500">
+              <a:defRPr sz="1600">
                 <a:solidFill>
                   <a:srgbClr val="94A3B8"/>
                 </a:solidFill>
@@ -4153,7 +4071,7 @@
               </a:defRPr>
             </a:pPr>
             <a:r>
-              <a:t>Feature Highlight 8: Personalised Career Blueprints</a:t>
+              <a:t>Feature Highlight 8: Standardized Skill Taxonomy &amp; Anti-Inflation Agent</a:t>
             </a:r>
           </a:p>
         </p:txBody>
@@ -4167,7 +4085,7 @@
         <p:spPr>
           <a:xfrm>
             <a:off x="731520" y="1645920"/>
-            <a:ext cx="4754880" cy="4572000"/>
+            <a:ext cx="10728655" cy="4572000"/>
           </a:xfrm>
           <a:prstGeom prst="roundRect">
             <a:avLst/>
@@ -4211,8 +4129,8 @@
         </p:nvSpPr>
         <p:spPr>
           <a:xfrm>
-            <a:off x="914400" y="1828800"/>
-            <a:ext cx="4389120" cy="4206240"/>
+            <a:off x="1097280" y="2011680"/>
+            <a:ext cx="9997135" cy="3840480"/>
           </a:xfrm>
           <a:prstGeom prst="rect">
             <a:avLst/>
@@ -4227,9 +4145,9 @@
           <a:p>
             <a:pPr>
               <a:spcAft>
-                <a:spcPts val="1400"/>
+                <a:spcPts val="2000"/>
               </a:spcAft>
-              <a:defRPr sz="1500">
+              <a:defRPr sz="1800">
                 <a:solidFill>
                   <a:srgbClr val="F1F5F9"/>
                 </a:solidFill>
@@ -4237,15 +4155,15 @@
               </a:defRPr>
             </a:pPr>
             <a:r>
-              <a:t>• Performs automated skill gap analysis against candidate profiles.</a:t>
+              <a:t>• Skill Standardization: Translates non-standard resume phrasing into unified skill terms for precise matching.</a:t>
             </a:r>
           </a:p>
           <a:p>
             <a:pPr>
               <a:spcAft>
-                <a:spcPts val="1400"/>
+                <a:spcPts val="2000"/>
               </a:spcAft>
-              <a:defRPr sz="1500">
+              <a:defRPr sz="1800">
                 <a:solidFill>
                   <a:srgbClr val="F1F5F9"/>
                 </a:solidFill>
@@ -4253,15 +4171,15 @@
               </a:defRPr>
             </a:pPr>
             <a:r>
-              <a:t>• Generates step-by-step milestones (Foundations, Advanced Tools, Real-World Projects).</a:t>
+              <a:t>• Candidate Claim Verification: Cross-checks resume experience bullets against actual GitHub repository commits to eliminate resume inflation.</a:t>
             </a:r>
           </a:p>
           <a:p>
             <a:pPr>
               <a:spcAft>
-                <a:spcPts val="1400"/>
+                <a:spcPts val="2000"/>
               </a:spcAft>
-              <a:defRPr sz="1500">
+              <a:defRPr sz="1800">
                 <a:solidFill>
                   <a:srgbClr val="F1F5F9"/>
                 </a:solidFill>
@@ -4269,88 +4187,7 @@
               </a:defRPr>
             </a:pPr>
             <a:r>
-              <a:t>• Includes estimated completion timeframes and recommended learning resources.</a:t>
-            </a:r>
-          </a:p>
-        </p:txBody>
-      </p:sp>
-      <p:sp>
-        <p:nvSpPr>
-          <p:cNvPr id="7" name="Rounded Rectangle 6"/>
-          <p:cNvSpPr/>
-          <p:nvPr/>
-        </p:nvSpPr>
-        <p:spPr>
-          <a:xfrm>
-            <a:off x="5760720" y="1645920"/>
-            <a:ext cx="5669280" cy="4572000"/>
-          </a:xfrm>
-          <a:prstGeom prst="roundRect">
-            <a:avLst/>
-          </a:prstGeom>
-          <a:solidFill>
-            <a:srgbClr val="18202F"/>
-          </a:solidFill>
-          <a:ln w="25400">
-            <a:solidFill>
-              <a:srgbClr val="A855F7"/>
-            </a:solidFill>
-          </a:ln>
-        </p:spPr>
-        <p:style>
-          <a:lnRef idx="1">
-            <a:schemeClr val="accent1"/>
-          </a:lnRef>
-          <a:fillRef idx="3">
-            <a:schemeClr val="accent1"/>
-          </a:fillRef>
-          <a:effectRef idx="2">
-            <a:schemeClr val="accent1"/>
-          </a:effectRef>
-          <a:fontRef idx="minor">
-            <a:schemeClr val="lt1"/>
-          </a:fontRef>
-        </p:style>
-        <p:txBody>
-          <a:bodyPr rtlCol="0" anchor="ctr"/>
-          <a:lstStyle/>
-          <a:p>
-            <a:pPr algn="ctr"/>
-          </a:p>
-        </p:txBody>
-      </p:sp>
-      <p:sp>
-        <p:nvSpPr>
-          <p:cNvPr id="8" name="TextBox 7"/>
-          <p:cNvSpPr txBox="1"/>
-          <p:nvPr/>
-        </p:nvSpPr>
-        <p:spPr>
-          <a:xfrm>
-            <a:off x="5943600" y="3291840"/>
-            <a:ext cx="5303520" cy="1645920"/>
-          </a:xfrm>
-          <a:prstGeom prst="rect">
-            <a:avLst/>
-          </a:prstGeom>
-          <a:noFill/>
-        </p:spPr>
-        <p:txBody>
-          <a:bodyPr wrap="square">
-            <a:spAutoFit/>
-          </a:bodyPr>
-          <a:lstStyle/>
-          <a:p>
-            <a:pPr algn="ctr">
-              <a:defRPr sz="1500" b="1">
-                <a:solidFill>
-                  <a:srgbClr val="A855F7"/>
-                </a:solidFill>
-                <a:latin typeface="Arial"/>
-              </a:defRPr>
-            </a:pPr>
-            <a:r>
-              <a:t>[ 🖼️ INSERT SCREENSHOT HERE: AI Roadmap Modal &amp; Milestone Progression ]</a:t>
+              <a:t>• Unbiased Career Guidance: Enforces fair evaluation standards across all candidate assessments and AI roadmaps.</a:t>
             </a:r>
           </a:p>
         </p:txBody>
@@ -4486,7 +4323,7 @@
           <a:lstStyle/>
           <a:p>
             <a:pPr>
-              <a:defRPr sz="2800" b="1">
+              <a:defRPr sz="3200" b="1">
                 <a:solidFill>
                   <a:srgbClr val="F1F5F9"/>
                 </a:solidFill>
@@ -4494,15 +4331,15 @@
               </a:defRPr>
             </a:pPr>
             <a:r>
-              <a:t>12. Playwright Scraping Microservice</a:t>
+              <a:t>12. Robust Database &amp; Data Modeling</a:t>
             </a:r>
           </a:p>
           <a:p>
             <a:pPr>
               <a:spcBef>
-                <a:spcPts val="400"/>
+                <a:spcPts val="600"/>
               </a:spcBef>
-              <a:defRPr sz="1500">
+              <a:defRPr sz="1600">
                 <a:solidFill>
                   <a:srgbClr val="94A3B8"/>
                 </a:solidFill>
@@ -4510,7 +4347,7 @@
               </a:defRPr>
             </a:pPr>
             <a:r>
-              <a:t>Feature Highlight 9: Async Scraping Dashboard</a:t>
+              <a:t>Structured Organization for User Profiles &amp; Vector Search</a:t>
             </a:r>
           </a:p>
         </p:txBody>
@@ -4524,7 +4361,7 @@
         <p:spPr>
           <a:xfrm>
             <a:off x="731520" y="1645920"/>
-            <a:ext cx="4754880" cy="4572000"/>
+            <a:ext cx="10728655" cy="4572000"/>
           </a:xfrm>
           <a:prstGeom prst="roundRect">
             <a:avLst/>
@@ -4568,8 +4405,8 @@
         </p:nvSpPr>
         <p:spPr>
           <a:xfrm>
-            <a:off x="914400" y="1828800"/>
-            <a:ext cx="4389120" cy="4206240"/>
+            <a:off x="1097280" y="2011680"/>
+            <a:ext cx="9997135" cy="3840480"/>
           </a:xfrm>
           <a:prstGeom prst="rect">
             <a:avLst/>
@@ -4584,9 +4421,9 @@
           <a:p>
             <a:pPr>
               <a:spcAft>
-                <a:spcPts val="1400"/>
+                <a:spcPts val="2000"/>
               </a:spcAft>
-              <a:defRPr sz="1500">
+              <a:defRPr sz="1800">
                 <a:solidFill>
                   <a:srgbClr val="F1F5F9"/>
                 </a:solidFill>
@@ -4594,15 +4431,15 @@
               </a:defRPr>
             </a:pPr>
             <a:r>
-              <a:t>• Autonomous Python microservice with Streamlit UI (http://localhost:8501).</a:t>
+              <a:t>• User Profile Records: Securely stores profile info, skill inventories, and target career goals.</a:t>
             </a:r>
           </a:p>
           <a:p>
             <a:pPr>
               <a:spcAft>
-                <a:spcPts val="1400"/>
+                <a:spcPts val="2000"/>
               </a:spcAft>
-              <a:defRPr sz="1500">
+              <a:defRPr sz="1800">
                 <a:solidFill>
                   <a:srgbClr val="F1F5F9"/>
                 </a:solidFill>
@@ -4610,15 +4447,15 @@
               </a:defRPr>
             </a:pPr>
             <a:r>
-              <a:t>• Dual-mode: Direct Playwright browser scraping &amp; Gemini Agentic scraping.</a:t>
+              <a:t>• Resume &amp; Diagnostic Logs: Manages raw text, structured extraction JSON, formatting flags, and historical ATS scores.</a:t>
             </a:r>
           </a:p>
           <a:p>
             <a:pPr>
               <a:spcAft>
-                <a:spcPts val="1400"/>
+                <a:spcPts val="2000"/>
               </a:spcAft>
-              <a:defRPr sz="1500">
+              <a:defRPr sz="1800">
                 <a:solidFill>
                   <a:srgbClr val="F1F5F9"/>
                 </a:solidFill>
@@ -4626,88 +4463,7 @@
               </a:defRPr>
             </a:pPr>
             <a:r>
-              <a:t>• Multi-format export: JSON, CSV, Markdown, Text, and Terraform (.tf).</a:t>
-            </a:r>
-          </a:p>
-        </p:txBody>
-      </p:sp>
-      <p:sp>
-        <p:nvSpPr>
-          <p:cNvPr id="7" name="Rounded Rectangle 6"/>
-          <p:cNvSpPr/>
-          <p:nvPr/>
-        </p:nvSpPr>
-        <p:spPr>
-          <a:xfrm>
-            <a:off x="5760720" y="1645920"/>
-            <a:ext cx="5669280" cy="4572000"/>
-          </a:xfrm>
-          <a:prstGeom prst="roundRect">
-            <a:avLst/>
-          </a:prstGeom>
-          <a:solidFill>
-            <a:srgbClr val="18202F"/>
-          </a:solidFill>
-          <a:ln w="25400">
-            <a:solidFill>
-              <a:srgbClr val="A855F7"/>
-            </a:solidFill>
-          </a:ln>
-        </p:spPr>
-        <p:style>
-          <a:lnRef idx="1">
-            <a:schemeClr val="accent1"/>
-          </a:lnRef>
-          <a:fillRef idx="3">
-            <a:schemeClr val="accent1"/>
-          </a:fillRef>
-          <a:effectRef idx="2">
-            <a:schemeClr val="accent1"/>
-          </a:effectRef>
-          <a:fontRef idx="minor">
-            <a:schemeClr val="lt1"/>
-          </a:fontRef>
-        </p:style>
-        <p:txBody>
-          <a:bodyPr rtlCol="0" anchor="ctr"/>
-          <a:lstStyle/>
-          <a:p>
-            <a:pPr algn="ctr"/>
-          </a:p>
-        </p:txBody>
-      </p:sp>
-      <p:sp>
-        <p:nvSpPr>
-          <p:cNvPr id="8" name="TextBox 7"/>
-          <p:cNvSpPr txBox="1"/>
-          <p:nvPr/>
-        </p:nvSpPr>
-        <p:spPr>
-          <a:xfrm>
-            <a:off x="5943600" y="3291840"/>
-            <a:ext cx="5303520" cy="1645920"/>
-          </a:xfrm>
-          <a:prstGeom prst="rect">
-            <a:avLst/>
-          </a:prstGeom>
-          <a:noFill/>
-        </p:spPr>
-        <p:txBody>
-          <a:bodyPr wrap="square">
-            <a:spAutoFit/>
-          </a:bodyPr>
-          <a:lstStyle/>
-          <a:p>
-            <a:pPr algn="ctr">
-              <a:defRPr sz="1500" b="1">
-                <a:solidFill>
-                  <a:srgbClr val="A855F7"/>
-                </a:solidFill>
-                <a:latin typeface="Arial"/>
-              </a:defRPr>
-            </a:pPr>
-            <a:r>
-              <a:t>[ 🖼️ INSERT SCREENSHOT HERE: Streamlit Web &amp; Resume Scraping Dashboard ]</a:t>
+              <a:t>• Job &amp; Vector Storage: Indexes high-dimensional vector representations for instant role matching queries.</a:t>
             </a:r>
           </a:p>
         </p:txBody>
@@ -4851,7 +4607,7 @@
               </a:defRPr>
             </a:pPr>
             <a:r>
-              <a:t>13. Database Schema &amp; Prisma ORM</a:t>
+              <a:t>13. Containerized Deployment &amp; Orchestration</a:t>
             </a:r>
           </a:p>
           <a:p>
@@ -4867,7 +4623,7 @@
               </a:defRPr>
             </a:pPr>
             <a:r>
-              <a:t>Robust Data Modeling for High-Performance Queries</a:t>
+              <a:t>Reliable &amp; Scalable Production Architecture</a:t>
             </a:r>
           </a:p>
         </p:txBody>
@@ -4951,7 +4707,7 @@
               </a:defRPr>
             </a:pPr>
             <a:r>
-              <a:t>• User &amp; Profile Schemas: Stores core details, career goals, and skills inventory.</a:t>
+              <a:t>• One-Click Environment Setup: Orchestrates the database, backend services, and scraping engines via Docker Compose.</a:t>
             </a:r>
           </a:p>
           <a:p>
@@ -4967,7 +4723,7 @@
               </a:defRPr>
             </a:pPr>
             <a:r>
-              <a:t>• Resume &amp; ATS Schemas: Stores raw text, parsed JSON chunks, and score breakdowns.</a:t>
+              <a:t>• Isolated Service Operations: Ensures web scraping, API handling, and frontend rendering operate smoothly without bottlenecking.</a:t>
             </a:r>
           </a:p>
           <a:p>
@@ -4983,7 +4739,7 @@
               </a:defRPr>
             </a:pPr>
             <a:r>
-              <a:t>• Job &amp; Vector Embeddings: Utilizes PostgreSQL vector type with HNSW index for lightning fast queries.</a:t>
+              <a:t>• Production-Ready Performance: Guarantees high availability and fast response times for concurrent users.</a:t>
             </a:r>
           </a:p>
         </p:txBody>
@@ -5127,7 +4883,7 @@
               </a:defRPr>
             </a:pPr>
             <a:r>
-              <a:t>14. Containerization &amp; Deployment</a:t>
+              <a:t>14. Conclusion &amp; Future Roadmap</a:t>
             </a:r>
           </a:p>
           <a:p>
@@ -5143,7 +4899,7 @@
               </a:defRPr>
             </a:pPr>
             <a:r>
-              <a:t>Docker Compose Microservice Orchestration</a:t>
+              <a:t>Transforming Career Growth with AI Intelligence</a:t>
             </a:r>
           </a:p>
         </p:txBody>
@@ -5227,7 +4983,7 @@
               </a:defRPr>
             </a:pPr>
             <a:r>
-              <a:t>• PostgreSQL Container: pgvector/pgvector:pg16 running on port 5432.</a:t>
+              <a:t>• Empowering Job Seekers: Replaces guesswork with clear ATS feedback, verified portfolio scores, and actionable learning roadmaps.</a:t>
             </a:r>
           </a:p>
           <a:p>
@@ -5243,7 +4999,7 @@
               </a:defRPr>
             </a:pPr>
             <a:r>
-              <a:t>• Web Scraper Container: Containerized Python 3.11 + Playwright environment on port 8501.</a:t>
+              <a:t>• Streamlining Recruitment: Helps hiring teams identify genuine engineering talent faster through verified code metrics.</a:t>
             </a:r>
           </a:p>
           <a:p>
@@ -5259,283 +5015,7 @@
               </a:defRPr>
             </a:pPr>
             <a:r>
-              <a:t>• Express &amp; Vite Services: Zero-downtime development and production build pipeline.</a:t>
-            </a:r>
-          </a:p>
-        </p:txBody>
-      </p:sp>
-    </p:spTree>
-  </p:cSld>
-  <p:clrMapOvr>
-    <a:masterClrMapping/>
-  </p:clrMapOvr>
-</p:sld>
-</file>
-
-<file path=ppt/slides/slide16.xml><?xml version="1.0" encoding="utf-8"?>
-<p:sld xmlns:a="http://schemas.openxmlformats.org/drawingml/2006/main" xmlns:p="http://schemas.openxmlformats.org/presentationml/2006/main" xmlns:r="http://schemas.openxmlformats.org/officeDocument/2006/relationships">
-  <p:cSld>
-    <p:spTree>
-      <p:nvGrpSpPr>
-        <p:cNvPr id="1" name=""/>
-        <p:cNvGrpSpPr/>
-        <p:nvPr/>
-      </p:nvGrpSpPr>
-      <p:grpSpPr/>
-      <p:sp>
-        <p:nvSpPr>
-          <p:cNvPr id="2" name="Rectangle 1"/>
-          <p:cNvSpPr/>
-          <p:nvPr/>
-        </p:nvSpPr>
-        <p:spPr>
-          <a:xfrm>
-            <a:off x="0" y="0"/>
-            <a:ext cx="12191695" cy="6858000"/>
-          </a:xfrm>
-          <a:prstGeom prst="rect">
-            <a:avLst/>
-          </a:prstGeom>
-          <a:solidFill>
-            <a:srgbClr val="0F172A"/>
-          </a:solidFill>
-          <a:ln>
-            <a:solidFill>
-              <a:srgbClr val="0F172A"/>
-            </a:solidFill>
-          </a:ln>
-        </p:spPr>
-        <p:style>
-          <a:lnRef idx="1">
-            <a:schemeClr val="accent1"/>
-          </a:lnRef>
-          <a:fillRef idx="3">
-            <a:schemeClr val="accent1"/>
-          </a:fillRef>
-          <a:effectRef idx="2">
-            <a:schemeClr val="accent1"/>
-          </a:effectRef>
-          <a:fontRef idx="minor">
-            <a:schemeClr val="lt1"/>
-          </a:fontRef>
-        </p:style>
-        <p:txBody>
-          <a:bodyPr rtlCol="0" anchor="ctr"/>
-          <a:lstStyle/>
-          <a:p>
-            <a:pPr algn="ctr"/>
-          </a:p>
-        </p:txBody>
-      </p:sp>
-      <p:sp>
-        <p:nvSpPr>
-          <p:cNvPr id="3" name="Rectangle 2"/>
-          <p:cNvSpPr/>
-          <p:nvPr/>
-        </p:nvSpPr>
-        <p:spPr>
-          <a:xfrm>
-            <a:off x="0" y="0"/>
-            <a:ext cx="12191695" cy="91440"/>
-          </a:xfrm>
-          <a:prstGeom prst="rect">
-            <a:avLst/>
-          </a:prstGeom>
-          <a:solidFill>
-            <a:srgbClr val="3B82F6"/>
-          </a:solidFill>
-          <a:ln>
-            <a:solidFill>
-              <a:srgbClr val="3B82F6"/>
-            </a:solidFill>
-          </a:ln>
-        </p:spPr>
-        <p:style>
-          <a:lnRef idx="1">
-            <a:schemeClr val="accent1"/>
-          </a:lnRef>
-          <a:fillRef idx="3">
-            <a:schemeClr val="accent1"/>
-          </a:fillRef>
-          <a:effectRef idx="2">
-            <a:schemeClr val="accent1"/>
-          </a:effectRef>
-          <a:fontRef idx="minor">
-            <a:schemeClr val="lt1"/>
-          </a:fontRef>
-        </p:style>
-        <p:txBody>
-          <a:bodyPr rtlCol="0" anchor="ctr"/>
-          <a:lstStyle/>
-          <a:p>
-            <a:pPr algn="ctr"/>
-          </a:p>
-        </p:txBody>
-      </p:sp>
-      <p:sp>
-        <p:nvSpPr>
-          <p:cNvPr id="4" name="TextBox 3"/>
-          <p:cNvSpPr txBox="1"/>
-          <p:nvPr/>
-        </p:nvSpPr>
-        <p:spPr>
-          <a:xfrm>
-            <a:off x="731520" y="365760"/>
-            <a:ext cx="10728655" cy="1097280"/>
-          </a:xfrm>
-          <a:prstGeom prst="rect">
-            <a:avLst/>
-          </a:prstGeom>
-          <a:noFill/>
-        </p:spPr>
-        <p:txBody>
-          <a:bodyPr wrap="square">
-            <a:spAutoFit/>
-          </a:bodyPr>
-          <a:lstStyle/>
-          <a:p>
-            <a:pPr>
-              <a:defRPr sz="3200" b="1">
-                <a:solidFill>
-                  <a:srgbClr val="F1F5F9"/>
-                </a:solidFill>
-                <a:latin typeface="Arial"/>
-              </a:defRPr>
-            </a:pPr>
-            <a:r>
-              <a:t>15. Conclusion &amp; Future Roadmap</a:t>
-            </a:r>
-          </a:p>
-          <a:p>
-            <a:pPr>
-              <a:spcBef>
-                <a:spcPts val="600"/>
-              </a:spcBef>
-              <a:defRPr sz="1600">
-                <a:solidFill>
-                  <a:srgbClr val="94A3B8"/>
-                </a:solidFill>
-                <a:latin typeface="Arial"/>
-              </a:defRPr>
-            </a:pPr>
-            <a:r>
-              <a:t>CareerPilot AI — Next Steps &amp; Impact</a:t>
-            </a:r>
-          </a:p>
-        </p:txBody>
-      </p:sp>
-      <p:sp>
-        <p:nvSpPr>
-          <p:cNvPr id="5" name="Rounded Rectangle 4"/>
-          <p:cNvSpPr/>
-          <p:nvPr/>
-        </p:nvSpPr>
-        <p:spPr>
-          <a:xfrm>
-            <a:off x="731520" y="1645920"/>
-            <a:ext cx="10728655" cy="4572000"/>
-          </a:xfrm>
-          <a:prstGeom prst="roundRect">
-            <a:avLst/>
-          </a:prstGeom>
-          <a:solidFill>
-            <a:srgbClr val="1E293B"/>
-          </a:solidFill>
-          <a:ln>
-            <a:solidFill>
-              <a:srgbClr val="475569"/>
-            </a:solidFill>
-          </a:ln>
-        </p:spPr>
-        <p:style>
-          <a:lnRef idx="1">
-            <a:schemeClr val="accent1"/>
-          </a:lnRef>
-          <a:fillRef idx="3">
-            <a:schemeClr val="accent1"/>
-          </a:fillRef>
-          <a:effectRef idx="2">
-            <a:schemeClr val="accent1"/>
-          </a:effectRef>
-          <a:fontRef idx="minor">
-            <a:schemeClr val="lt1"/>
-          </a:fontRef>
-        </p:style>
-        <p:txBody>
-          <a:bodyPr rtlCol="0" anchor="ctr"/>
-          <a:lstStyle/>
-          <a:p>
-            <a:pPr algn="ctr"/>
-          </a:p>
-        </p:txBody>
-      </p:sp>
-      <p:sp>
-        <p:nvSpPr>
-          <p:cNvPr id="6" name="TextBox 5"/>
-          <p:cNvSpPr txBox="1"/>
-          <p:nvPr/>
-        </p:nvSpPr>
-        <p:spPr>
-          <a:xfrm>
-            <a:off x="1097280" y="2011680"/>
-            <a:ext cx="9997135" cy="3840480"/>
-          </a:xfrm>
-          <a:prstGeom prst="rect">
-            <a:avLst/>
-          </a:prstGeom>
-          <a:noFill/>
-        </p:spPr>
-        <p:txBody>
-          <a:bodyPr wrap="square">
-            <a:spAutoFit/>
-          </a:bodyPr>
-          <a:lstStyle/>
-          <a:p>
-            <a:pPr>
-              <a:spcAft>
-                <a:spcPts val="2000"/>
-              </a:spcAft>
-              <a:defRPr sz="1800">
-                <a:solidFill>
-                  <a:srgbClr val="F1F5F9"/>
-                </a:solidFill>
-                <a:latin typeface="Arial"/>
-              </a:defRPr>
-            </a:pPr>
-            <a:r>
-              <a:t>• Impact: Empowers job seekers with data-driven clarity and ATS compatibility.</a:t>
-            </a:r>
-          </a:p>
-          <a:p>
-            <a:pPr>
-              <a:spcAft>
-                <a:spcPts val="2000"/>
-              </a:spcAft>
-              <a:defRPr sz="1800">
-                <a:solidFill>
-                  <a:srgbClr val="F1F5F9"/>
-                </a:solidFill>
-                <a:latin typeface="Arial"/>
-              </a:defRPr>
-            </a:pPr>
-            <a:r>
-              <a:t>• Upcoming Features: Real-time mock interview simulator, auto-tailored cover letter generator, and live recruiter connection portal.</a:t>
-            </a:r>
-          </a:p>
-          <a:p>
-            <a:pPr>
-              <a:spcAft>
-                <a:spcPts val="2000"/>
-              </a:spcAft>
-              <a:defRPr sz="1800">
-                <a:solidFill>
-                  <a:srgbClr val="F1F5F9"/>
-                </a:solidFill>
-                <a:latin typeface="Arial"/>
-              </a:defRPr>
-            </a:pPr>
-            <a:r>
-              <a:t>• Thank You! All source code available at Team-Placebo repository.</a:t>
+              <a:t>• Upcoming Capabilities: Expanding into interactive AI mock interviews and automated resume customization per job posting.</a:t>
             </a:r>
           </a:p>
         </p:txBody>
@@ -5695,7 +5175,7 @@
               </a:defRPr>
             </a:pPr>
             <a:r>
-              <a:t>The Limitations of Traditional Recruitment &amp; Job Search</a:t>
+              <a:t>Challenges Job Seekers &amp; Hiring Teams Face Today</a:t>
             </a:r>
           </a:p>
         </p:txBody>
@@ -5779,7 +5259,7 @@
               </a:defRPr>
             </a:pPr>
             <a:r>
-              <a:t>• Rigid Keyword Matching: Traditional ATS screeners reject candidates based on exact string matches, ignoring real technical capability.</a:t>
+              <a:t>• Flawed Keyword Screening: Traditional ATS portals reject qualified talent simply because exact keyword strings are missing from their resumes.</a:t>
             </a:r>
           </a:p>
           <a:p>
@@ -5795,7 +5275,7 @@
               </a:defRPr>
             </a:pPr>
             <a:r>
-              <a:t>• Static Resumes vs Dynamic Portfolios: PDF resumes fail to reflect actual coding output, commit frequency, or open-source impact.</a:t>
+              <a:t>• Unverified Candidate Claims: Static PDF resumes fail to reflect actual coding ability, commit frequency, or real engineering impact.</a:t>
             </a:r>
           </a:p>
           <a:p>
@@ -5811,7 +5291,7 @@
               </a:defRPr>
             </a:pPr>
             <a:r>
-              <a:t>• Unclear Skill Progression: Job seekers lack personalized, data-driven roadmaps to bridge their specific skill gaps.</a:t>
+              <a:t>• Lack of Actionable Career Guidance: Rejected applicants receive zero feedback on missing skills or how to bridge gaps for target roles.</a:t>
             </a:r>
           </a:p>
         </p:txBody>
@@ -5971,7 +5451,7 @@
               </a:defRPr>
             </a:pPr>
             <a:r>
-              <a:t>An End-to-End AI &amp; Vector-Search Career Acceleration Ecosystem</a:t>
+              <a:t>Empowering Job Seekers &amp; Recruiters with Intelligence</a:t>
             </a:r>
           </a:p>
         </p:txBody>
@@ -6055,7 +5535,7 @@
               </a:defRPr>
             </a:pPr>
             <a:r>
-              <a:t>• Semantic Vector Matching: High-dimensional embeddings with PostgreSQL pgvector to match context, not just keywords.</a:t>
+              <a:t>• Contextual Semantic Matching: Evaluates candidate experience based on conceptual skill meaning rather than primitive word matching.</a:t>
             </a:r>
           </a:p>
           <a:p>
@@ -6071,7 +5551,7 @@
               </a:defRPr>
             </a:pPr>
             <a:r>
-              <a:t>• Automated GitHub Portfolio Analysis: Direct integration with GitHub API to compute real technical capability scores.</a:t>
+              <a:t>• Verified Code Quantification: Connects directly to GitHub to calculate objective developer performance scores from real code activity.</a:t>
             </a:r>
           </a:p>
           <a:p>
@@ -6087,7 +5567,7 @@
               </a:defRPr>
             </a:pPr>
             <a:r>
-              <a:t>• Dynamic AI Roadmap Engine: Tailored step-by-step milestones to bridge candidate skill gaps for target roles.</a:t>
+              <a:t>• Personalized Growth Roadmaps: Automatically detects candidate skill gaps for any role and constructs step-by-step learning blueprints.</a:t>
             </a:r>
           </a:p>
         </p:txBody>
@@ -6247,7 +5727,7 @@
               </a:defRPr>
             </a:pPr>
             <a:r>
-              <a:t>Modern Full-Stack Microservice Ecosystem</a:t>
+              <a:t>High-Level Data Flow &amp; Modular Platform Structure</a:t>
             </a:r>
           </a:p>
         </p:txBody>
@@ -6331,7 +5811,7 @@
               </a:defRPr>
             </a:pPr>
             <a:r>
-              <a:t>• Frontend: React 18 + Vite + TypeScript + Tailwind CSS (Dark Glassmorphic UI)</a:t>
+              <a:t>• Data Capture: Accepts PDF/Word resumes, GitHub profile links, and live web job postings.</a:t>
             </a:r>
           </a:p>
           <a:p>
@@ -6347,7 +5827,7 @@
               </a:defRPr>
             </a:pPr>
             <a:r>
-              <a:t>• Backend API: Node.js + Express + TypeScript + Prisma ORM</a:t>
+              <a:t>• AI Processing Layer: Normalizes skill terms, parses candidate content, and calculates ATS readability &amp; impact metrics.</a:t>
             </a:r>
           </a:p>
           <a:p>
@@ -6363,7 +5843,7 @@
               </a:defRPr>
             </a:pPr>
             <a:r>
-              <a:t>• Database: PostgreSQL 16 + pgvector (HNSW Indexing for vector search)</a:t>
+              <a:t>• Vector Search Core: Matches candidate vectors against industry job datasets using high-performance similarity search.</a:t>
             </a:r>
           </a:p>
           <a:p>
@@ -6379,7 +5859,7 @@
               </a:defRPr>
             </a:pPr>
             <a:r>
-              <a:t>• Microservice: Python 3.11 + Playwright Async Browser Scraper + Streamlit Dashboard</a:t>
+              <a:t>• User Interface: Renders interactive dashboards, ATS score breakdowns, and milestone roadmaps.</a:t>
             </a:r>
           </a:p>
         </p:txBody>
@@ -6523,7 +6003,7 @@
               </a:defRPr>
             </a:pPr>
             <a:r>
-              <a:t>4. Modern Glassmorphic Dashboard</a:t>
+              <a:t>4. Glassmorphic User Dashboard</a:t>
             </a:r>
           </a:p>
           <a:p>
@@ -6539,7 +6019,7 @@
               </a:defRPr>
             </a:pPr>
             <a:r>
-              <a:t>Feature Highlight 1: Unified Dark Mode Interface</a:t>
+              <a:t>Feature Highlight 1: Unified Dark-Mode Command Center</a:t>
             </a:r>
           </a:p>
         </p:txBody>
@@ -6623,7 +6103,7 @@
               </a:defRPr>
             </a:pPr>
             <a:r>
-              <a:t>• Cyberpunk-inspired glassmorphism with high-contrast UI tokens.</a:t>
+              <a:t>• Central Command Hub: Allows candidates to manage their profile, view target roles, track scores, and explore roadmaps in one place.</a:t>
             </a:r>
           </a:p>
           <a:p>
@@ -6639,7 +6119,7 @@
               </a:defRPr>
             </a:pPr>
             <a:r>
-              <a:t>• Live navigation across Portfolio, ATS Scoring, Role Analysis, and AI Roadmaps.</a:t>
+              <a:t>• Real-Time Stats Display: Instantly highlights overall ATS compatibility, portfolio strength, and recommended next steps.</a:t>
             </a:r>
           </a:p>
           <a:p>
@@ -6655,7 +6135,7 @@
               </a:defRPr>
             </a:pPr>
             <a:r>
-              <a:t>• Responsive dashboard layouts optimized for all display sizes.</a:t>
+              <a:t>• Fluid User Experience: Features modern glassmorphism visuals designed for effortless navigation and clarity.</a:t>
             </a:r>
           </a:p>
         </p:txBody>
@@ -6896,7 +6376,7 @@
               </a:defRPr>
             </a:pPr>
             <a:r>
-              <a:t>Feature Highlight 2: Real-World Code Quantification</a:t>
+              <a:t>Feature Highlight 2: Code Verification &amp; Technical Scoring (3 Screenshot Slots)</a:t>
             </a:r>
           </a:p>
         </p:txBody>
@@ -6980,7 +6460,7 @@
               </a:defRPr>
             </a:pPr>
             <a:r>
-              <a:t>• Extracts public repositories, commit velocity, languages, and star counts.</a:t>
+              <a:t>• Live Code Analysis: Analyzes public repositories, commit velocity, code syntax, and star counts directly from GitHub.</a:t>
             </a:r>
           </a:p>
           <a:p>
@@ -6996,7 +6476,7 @@
               </a:defRPr>
             </a:pPr>
             <a:r>
-              <a:t>• Calculates objective Technical Portfolio Score (0-100%).</a:t>
+              <a:t>• Objective Developer Score: Converts real activity into a verified Technical Portfolio Score (0-100%).</a:t>
             </a:r>
           </a:p>
           <a:p>
@@ -7012,7 +6492,7 @@
               </a:defRPr>
             </a:pPr>
             <a:r>
-              <a:t>• Provides stack distribution breakdown (Frontend, Backend, DevOps, AI).</a:t>
+              <a:t>• Stack Breakdown: Displays clear visual charts of language distribution (Frontend, Backend, AI, DevOps).</a:t>
             </a:r>
           </a:p>
         </p:txBody>
@@ -7026,7 +6506,88 @@
         <p:spPr>
           <a:xfrm>
             <a:off x="5760720" y="1645920"/>
-            <a:ext cx="5669280" cy="4572000"/>
+            <a:ext cx="5669280" cy="1371600"/>
+          </a:xfrm>
+          <a:prstGeom prst="roundRect">
+            <a:avLst/>
+          </a:prstGeom>
+          <a:solidFill>
+            <a:srgbClr val="18202F"/>
+          </a:solidFill>
+          <a:ln w="25400">
+            <a:solidFill>
+              <a:srgbClr val="3B82F6"/>
+            </a:solidFill>
+          </a:ln>
+        </p:spPr>
+        <p:style>
+          <a:lnRef idx="1">
+            <a:schemeClr val="accent1"/>
+          </a:lnRef>
+          <a:fillRef idx="3">
+            <a:schemeClr val="accent1"/>
+          </a:fillRef>
+          <a:effectRef idx="2">
+            <a:schemeClr val="accent1"/>
+          </a:effectRef>
+          <a:fontRef idx="minor">
+            <a:schemeClr val="lt1"/>
+          </a:fontRef>
+        </p:style>
+        <p:txBody>
+          <a:bodyPr rtlCol="0" anchor="ctr"/>
+          <a:lstStyle/>
+          <a:p>
+            <a:pPr algn="ctr"/>
+          </a:p>
+        </p:txBody>
+      </p:sp>
+      <p:sp>
+        <p:nvSpPr>
+          <p:cNvPr id="8" name="TextBox 7"/>
+          <p:cNvSpPr txBox="1"/>
+          <p:nvPr/>
+        </p:nvSpPr>
+        <p:spPr>
+          <a:xfrm>
+            <a:off x="5852160" y="2011680"/>
+            <a:ext cx="5486400" cy="731520"/>
+          </a:xfrm>
+          <a:prstGeom prst="rect">
+            <a:avLst/>
+          </a:prstGeom>
+          <a:noFill/>
+        </p:spPr>
+        <p:txBody>
+          <a:bodyPr wrap="square">
+            <a:spAutoFit/>
+          </a:bodyPr>
+          <a:lstStyle/>
+          <a:p>
+            <a:pPr algn="ctr">
+              <a:defRPr sz="1300" b="1">
+                <a:solidFill>
+                  <a:srgbClr val="3B82F6"/>
+                </a:solidFill>
+                <a:latin typeface="Arial"/>
+              </a:defRPr>
+            </a:pPr>
+            <a:r>
+              <a:t>[ 🖼️ Image Slot 1: GitHub Profile Analysis &amp; Developer Score ]</a:t>
+            </a:r>
+          </a:p>
+        </p:txBody>
+      </p:sp>
+      <p:sp>
+        <p:nvSpPr>
+          <p:cNvPr id="9" name="Rounded Rectangle 8"/>
+          <p:cNvSpPr/>
+          <p:nvPr/>
+        </p:nvSpPr>
+        <p:spPr>
+          <a:xfrm>
+            <a:off x="5760720" y="3246120"/>
+            <a:ext cx="5669280" cy="1371600"/>
           </a:xfrm>
           <a:prstGeom prst="roundRect">
             <a:avLst/>
@@ -7064,14 +6625,14 @@
       </p:sp>
       <p:sp>
         <p:nvSpPr>
-          <p:cNvPr id="8" name="TextBox 7"/>
+          <p:cNvPr id="10" name="TextBox 9"/>
           <p:cNvSpPr txBox="1"/>
           <p:nvPr/>
         </p:nvSpPr>
         <p:spPr>
           <a:xfrm>
-            <a:off x="5943600" y="3291840"/>
-            <a:ext cx="5303520" cy="1645920"/>
+            <a:off x="5852160" y="3611879"/>
+            <a:ext cx="5486400" cy="731520"/>
           </a:xfrm>
           <a:prstGeom prst="rect">
             <a:avLst/>
@@ -7085,7 +6646,7 @@
           <a:lstStyle/>
           <a:p>
             <a:pPr algn="ctr">
-              <a:defRPr sz="1500" b="1">
+              <a:defRPr sz="1300" b="1">
                 <a:solidFill>
                   <a:srgbClr val="A855F7"/>
                 </a:solidFill>
@@ -7093,7 +6654,88 @@
               </a:defRPr>
             </a:pPr>
             <a:r>
-              <a:t>[ 🖼️ INSERT SCREENSHOT HERE: GitHub Portfolio Analyzer Dashboard ]</a:t>
+              <a:t>[ 🖼️ Image Slot 2: Repository Metrics &amp; Commit Velocity Chart ]</a:t>
+            </a:r>
+          </a:p>
+        </p:txBody>
+      </p:sp>
+      <p:sp>
+        <p:nvSpPr>
+          <p:cNvPr id="11" name="Rounded Rectangle 10"/>
+          <p:cNvSpPr/>
+          <p:nvPr/>
+        </p:nvSpPr>
+        <p:spPr>
+          <a:xfrm>
+            <a:off x="5760720" y="4846320"/>
+            <a:ext cx="5669280" cy="1371600"/>
+          </a:xfrm>
+          <a:prstGeom prst="roundRect">
+            <a:avLst/>
+          </a:prstGeom>
+          <a:solidFill>
+            <a:srgbClr val="18202F"/>
+          </a:solidFill>
+          <a:ln w="25400">
+            <a:solidFill>
+              <a:srgbClr val="10B981"/>
+            </a:solidFill>
+          </a:ln>
+        </p:spPr>
+        <p:style>
+          <a:lnRef idx="1">
+            <a:schemeClr val="accent1"/>
+          </a:lnRef>
+          <a:fillRef idx="3">
+            <a:schemeClr val="accent1"/>
+          </a:fillRef>
+          <a:effectRef idx="2">
+            <a:schemeClr val="accent1"/>
+          </a:effectRef>
+          <a:fontRef idx="minor">
+            <a:schemeClr val="lt1"/>
+          </a:fontRef>
+        </p:style>
+        <p:txBody>
+          <a:bodyPr rtlCol="0" anchor="ctr"/>
+          <a:lstStyle/>
+          <a:p>
+            <a:pPr algn="ctr"/>
+          </a:p>
+        </p:txBody>
+      </p:sp>
+      <p:sp>
+        <p:nvSpPr>
+          <p:cNvPr id="12" name="TextBox 11"/>
+          <p:cNvSpPr txBox="1"/>
+          <p:nvPr/>
+        </p:nvSpPr>
+        <p:spPr>
+          <a:xfrm>
+            <a:off x="5852160" y="5212080"/>
+            <a:ext cx="5486400" cy="731520"/>
+          </a:xfrm>
+          <a:prstGeom prst="rect">
+            <a:avLst/>
+          </a:prstGeom>
+          <a:noFill/>
+        </p:spPr>
+        <p:txBody>
+          <a:bodyPr wrap="square">
+            <a:spAutoFit/>
+          </a:bodyPr>
+          <a:lstStyle/>
+          <a:p>
+            <a:pPr algn="ctr">
+              <a:defRPr sz="1300" b="1">
+                <a:solidFill>
+                  <a:srgbClr val="10B981"/>
+                </a:solidFill>
+                <a:latin typeface="Arial"/>
+              </a:defRPr>
+            </a:pPr>
+            <a:r>
+              <a:t>[ 🖼️ Image Slot 3: Tech Stack Breakdown &amp; Language Distribution ]</a:t>
             </a:r>
           </a:p>
         </p:txBody>
@@ -7237,7 +6879,7 @@
               </a:defRPr>
             </a:pPr>
             <a:r>
-              <a:t>6. Resume Upload &amp; Extraction Engine</a:t>
+              <a:t>6. Resume Parsing &amp; ATS Diagnostic Suite</a:t>
             </a:r>
           </a:p>
           <a:p>
@@ -7253,7 +6895,7 @@
               </a:defRPr>
             </a:pPr>
             <a:r>
-              <a:t>Feature Highlight 3: AI Document Parsing</a:t>
+              <a:t>Feature Highlight 3: Document Upload, Readability Check &amp; Compatibility Scoring</a:t>
             </a:r>
           </a:p>
         </p:txBody>
@@ -7337,7 +6979,7 @@
               </a:defRPr>
             </a:pPr>
             <a:r>
-              <a:t>• Supports PDF, DOCX, and TXT resume file uploads.</a:t>
+              <a:t>• Seamless Upload &amp; Extraction: Accepts PDF, Word, or text CVs and extracts structured experience, skills, and contact details.</a:t>
             </a:r>
           </a:p>
           <a:p>
@@ -7353,7 +6995,7 @@
               </a:defRPr>
             </a:pPr>
             <a:r>
-              <a:t>• Extracts structured JSON schema using Google Gemini AI.</a:t>
+              <a:t>• Formatting &amp; Readability Inspection: Verifies optimal word count (100-1000 words), bullet point density, and machine parseability.</a:t>
             </a:r>
           </a:p>
           <a:p>
@@ -7369,7 +7011,7 @@
               </a:defRPr>
             </a:pPr>
             <a:r>
-              <a:t>• Categorizes skills, work experiences, education, and impact statements.</a:t>
+              <a:t>• Weighted ATS Compatibility Score: Computes an overall 0-100% score (45% Skills, 25% Impact, 25% Readability, 10% Structure) and provides a checkbox task list to fix issues.</a:t>
             </a:r>
           </a:p>
         </p:txBody>
@@ -7450,7 +7092,7 @@
               </a:defRPr>
             </a:pPr>
             <a:r>
-              <a:t>[ 🖼️ INSERT SCREENSHOT HERE: Resume Upload &amp; Structured JSON View ]</a:t>
+              <a:t>[ 🖼️ INSERT SCREENSHOT HERE: Resume Upload, ATS Score Gauge &amp; Formatting Checklist ]</a:t>
             </a:r>
           </a:p>
         </p:txBody>
@@ -7594,7 +7236,7 @@
               </a:defRPr>
             </a:pPr>
             <a:r>
-              <a:t>7. Automated ATS Compatibility Scoring</a:t>
+              <a:t>7. Intelligent Vector Search Job Matching</a:t>
             </a:r>
           </a:p>
           <a:p>
@@ -7610,7 +7252,7 @@
               </a:defRPr>
             </a:pPr>
             <a:r>
-              <a:t>Feature Highlight 4: Real-Life Recruiter Weightage Engine</a:t>
+              <a:t>Feature Highlight 4: Contextual Career Role Recommendations</a:t>
             </a:r>
           </a:p>
         </p:txBody>
@@ -7694,7 +7336,7 @@
               </a:defRPr>
             </a:pPr>
             <a:r>
-              <a:t>• 45% Keyword &amp; Skill Density Match</a:t>
+              <a:t>• Contextual Understanding: Evaluates candidates against job openings based on underlying meaning rather than strict word matches.</a:t>
             </a:r>
           </a:p>
           <a:p>
@@ -7710,7 +7352,7 @@
               </a:defRPr>
             </a:pPr>
             <a:r>
-              <a:t>• 25% Measurable Experience Impact</a:t>
+              <a:t>• Sub-Millisecond Matches: Instantly computes similarity match percentages (e.g. 88% Match) across thousands of roles.</a:t>
             </a:r>
           </a:p>
           <a:p>
@@ -7726,23 +7368,7 @@
               </a:defRPr>
             </a:pPr>
             <a:r>
-              <a:t>• 25% Readability &amp; Machine-Parseability</a:t>
-            </a:r>
-          </a:p>
-          <a:p>
-            <a:pPr>
-              <a:spcAft>
-                <a:spcPts val="1400"/>
-              </a:spcAft>
-              <a:defRPr sz="1500">
-                <a:solidFill>
-                  <a:srgbClr val="F1F5F9"/>
-                </a:solidFill>
-                <a:latin typeface="Arial"/>
-              </a:defRPr>
-            </a:pPr>
-            <a:r>
-              <a:t>• 10% Document Structure &amp; Completeness</a:t>
+              <a:t>• Interactive Job Explorer: Allows users to click on any job listing to view detailed requirements and instant skill gap comparisons.</a:t>
             </a:r>
           </a:p>
         </p:txBody>
@@ -7823,7 +7449,7 @@
               </a:defRPr>
             </a:pPr>
             <a:r>
-              <a:t>[ 🖼️ INSERT SCREENSHOT HERE: ATS Score Gauge &amp; Point Breakdown Chart ]</a:t>
+              <a:t>[ 🖼️ INSERT SCREENSHOT HERE: Job Matching Cards &amp; Similarity Percentage Badges ]</a:t>
             </a:r>
           </a:p>
         </p:txBody>
@@ -7967,7 +7593,7 @@
               </a:defRPr>
             </a:pPr>
             <a:r>
-              <a:t>8. Formatting Diagnostics &amp; Readability Check</a:t>
+              <a:t>8. Kaggle AI Job Dataset Ingestion</a:t>
             </a:r>
           </a:p>
           <a:p>
@@ -7983,7 +7609,7 @@
               </a:defRPr>
             </a:pPr>
             <a:r>
-              <a:t>Feature Highlight 5: Automated Document Inspection</a:t>
+              <a:t>Feature Highlight 5: Real-World Industry Benchmarks</a:t>
             </a:r>
           </a:p>
         </p:txBody>
@@ -8067,7 +7693,7 @@
               </a:defRPr>
             </a:pPr>
             <a:r>
-              <a:t>• Length Verification: Ensures optimal word count range (100 - 1000 words).</a:t>
+              <a:t>• Massive Data Catalog: Ingests thousands of active engineering job postings to provide real-world industry benchmarks.</a:t>
             </a:r>
           </a:p>
           <a:p>
@@ -8083,7 +7709,7 @@
               </a:defRPr>
             </a:pPr>
             <a:r>
-              <a:t>• Bullet Density Analysis: Requires standard ATS bullet structures.</a:t>
+              <a:t>• Skill Demand Insights: Shows candidates what skills are currently trending and most requested in their field.</a:t>
             </a:r>
           </a:p>
           <a:p>
@@ -8099,7 +7725,7 @@
               </a:defRPr>
             </a:pPr>
             <a:r>
-              <a:t>• Generates interactive To-Do checklist for instant candidate formatting fixes.</a:t>
+              <a:t>• Market Salary Standards: Helps candidates align their career expectations with current industry standards.</a:t>
             </a:r>
           </a:p>
         </p:txBody>
@@ -8180,7 +7806,7 @@
               </a:defRPr>
             </a:pPr>
             <a:r>
-              <a:t>[ 🖼️ INSERT SCREENSHOT HERE: Formatting Diagnostics &amp; Issue Checklist ]</a:t>
+              <a:t>[ 🖼️ INSERT SCREENSHOT HERE: Kaggle AI Dataset Search &amp; Industry Role Benchmarks ]</a:t>
             </a:r>
           </a:p>
         </p:txBody>

</xml_diff>